<commit_message>
Uniformiser Agri-Impact et harmoniser le style vert et orange
</commit_message>
<xml_diff>
--- a/docs/S2.4/AgriImpact_Pitch_Deck_v0.pptx
+++ b/docs/S2.4/AgriImpact_Pitch_Deck_v0.pptx
@@ -509,7 +509,7 @@
           <a:lstStyle/>
           <a:p>
             <a:r>
-              <a:t>Imaginez un agriculteur qui doit raconter à nouveau son exploitation à chaque nouveau projet. Ses terres, ses activités et ses échanges avec le conseiller existent, mais restent dispersés. AgriImpact propose de relier ces informations pour préparer la suite sans perdre la mémoire du passé. Voici notre prototype de démonstration. [25 secondes]</a:t>
+              <a:t>Imaginez un agriculteur qui doit raconter à nouveau son exploitation à chaque nouveau projet. Ses terres, ses activités et ses échanges avec le conseiller existent, mais restent dispersés. Agri-Impact propose de relier ces informations pour préparer la suite sans perdre la mémoire du passé. Voici notre prototype de démonstration. [25 secondes]</a:t>
             </a:r>
           </a:p>
         </p:txBody>
@@ -4047,7 +4047,7 @@
               </a:defRPr>
             </a:pPr>
             <a:r>
-              <a:t>AGRIIMPACT  /  PITCH DECK v0</a:t>
+              <a:t>Agri-Impact  /  PITCH DECK v0</a:t>
             </a:r>
           </a:p>
         </p:txBody>
@@ -4141,7 +4141,7 @@
               </a:defRPr>
             </a:pPr>
             <a:r>
-              <a:t>AgriImpact relie l’agriculteur, son exploitation et son conseiller.</a:t>
+              <a:t>Agri-Impact relie l’agriculteur, son exploitation et son conseiller.</a:t>
             </a:r>
           </a:p>
         </p:txBody>
@@ -4464,7 +4464,7 @@
               </a:defRPr>
             </a:pPr>
             <a:r>
-              <a:t>AGRIIMPACT  /  PITCH DECK v0</a:t>
+              <a:t>Agri-Impact  /  PITCH DECK v0</a:t>
             </a:r>
           </a:p>
         </p:txBody>
@@ -5247,7 +5247,7 @@
               </a:defRPr>
             </a:pPr>
             <a:r>
-              <a:t>AGRIIMPACT  /  PITCH DECK v0</a:t>
+              <a:t>Agri-Impact  /  PITCH DECK v0</a:t>
             </a:r>
           </a:p>
         </p:txBody>
@@ -5684,7 +5684,7 @@
               </a:defRPr>
             </a:pPr>
             <a:r>
-              <a:t>AGRIIMPACT  /  PITCH DECK v0</a:t>
+              <a:t>Agri-Impact  /  PITCH DECK v0</a:t>
             </a:r>
           </a:p>
         </p:txBody>
@@ -6137,7 +6137,7 @@
               </a:defRPr>
             </a:pPr>
             <a:r>
-              <a:t>AGRIIMPACT  /  PITCH DECK v0</a:t>
+              <a:t>Agri-Impact  /  PITCH DECK v0</a:t>
             </a:r>
           </a:p>
         </p:txBody>
@@ -6551,7 +6551,7 @@
               </a:defRPr>
             </a:pPr>
             <a:r>
-              <a:t>AGRIIMPACT  /  PITCH DECK v0</a:t>
+              <a:t>Agri-Impact  /  PITCH DECK v0</a:t>
             </a:r>
           </a:p>
         </p:txBody>
@@ -7153,7 +7153,7 @@
               </a:defRPr>
             </a:pPr>
             <a:r>
-              <a:t>AGRIIMPACT  /  PITCH DECK v0</a:t>
+              <a:t>Agri-Impact  /  PITCH DECK v0</a:t>
             </a:r>
           </a:p>
         </p:txBody>
@@ -7858,7 +7858,7 @@
               </a:defRPr>
             </a:pPr>
             <a:r>
-              <a:t>AGRIIMPACT  /  PITCH DECK v0</a:t>
+              <a:t>Agri-Impact  /  PITCH DECK v0</a:t>
             </a:r>
           </a:p>
         </p:txBody>

</xml_diff>